<commit_message>
Gate on level_at_anchor per owner decision
Owner decision 2026-08-09: the frozen model's only production job is
predicting demand at the reference discount -- inference always
overwrites price to d_ref and the parametric layer handles every other
price -- so the calibration gate now judges level_bias_at_anchor against
the [0.90, 1.10] band instead of the pooled at-actual-prices ratio,
which was shown to be dominated by the unidentifiable prior's slope
(anchor ~1.0 over five months, pooled 1.17). The pooled ratio and
slope-by-gap stay reported as diagnostics; slope is validated by
posterior movement and the A/B, with the daily drift ratio as the
production guard. Config default flipped with rationale; design doc
gate section rewritten; AGENTS reading guide updated; deck gate wording
regenerated.

Co-Authored-By: Claude Fable 5 <noreply@anthropic.com>
Claude-Session: https://claude.ai/code/session_01YKcvi2BxiHvexgFxeXEDXu
</commit_message>
<xml_diff>
--- a/docs/perishable_markdown_tech_deck.pptx
+++ b/docs/perishable_markdown_tech_deck.pptx
@@ -2564,7 +2564,7 @@
                 <a:ea typeface="Calibri" pitchFamily="34" charset="-122"/>
                 <a:cs typeface="Calibri" pitchFamily="34" charset="-120"/>
               </a:rPr>
-              <a:t>Gate band set from measured volatility  ·  [0.90, 1.10]</a:t>
+              <a:t>Gate: level-at-anchor · band [0.90, 1.10] from measured volatility</a:t>
             </a:r>
             <a:endParaRPr lang="en-US" sz="1500" dirty="0"/>
           </a:p>
@@ -3888,7 +3888,7 @@
                           <a:ea typeface="Calibri" pitchFamily="34" charset="-122"/>
                           <a:cs typeface="Calibri" pitchFamily="34" charset="-120"/>
                         </a:rPr>
-                        <a:t>band [0.90, 1.10] (owner, ≈2σ)</a:t>
+                        <a:t>level-at-anchor · band [0.90, 1.10]</a:t>
                       </a:r>
                       <a:endParaRPr lang="en-US" sz="1150" dirty="0">
                         <a:latin typeface="Calibri" charset="0"/>
@@ -3953,7 +3953,7 @@
                           <a:ea typeface="Calibri" pitchFamily="34" charset="-122"/>
                           <a:cs typeface="Calibri" pitchFamily="34" charset="-120"/>
                         </a:rPr>
-                        <a:t>Calibrated re-run of the v2 model in progress; final retrain + re-fit at launch freeze</a:t>
+                        <a:t>Gates the frozen artifact on its own job — the level at reference price; slope belongs to production learning (owner, 2026-08-09)</a:t>
                       </a:r>
                       <a:endParaRPr lang="en-US" sz="1150" dirty="0">
                         <a:latin typeface="Calibri" charset="0"/>

</xml_diff>